<commit_message>
Apresentações com falas: remove o caminhão dos últimos slides
Co-Authored-By: Claude Opus 5.5 <noreply@anthropic.com>
Claude-Session: https://claude.ai/code/session_019UKDqx9VshcyuwTFbJxj3E
</commit_message>
<xml_diff>
--- a/apresentacoes/Reducao-de-Perdas-de-Agua-NorteSul-com-falas.pptx
+++ b/apresentacoes/Reducao-de-Perdas-de-Agua-NorteSul-com-falas.pptx
@@ -2925,33 +2925,9 @@
           </a:p>
         </p:txBody>
       </p:sp>
-      <p:pic>
-        <p:nvPicPr>
-          <p:cNvPr id="7" name="Image 0" descr="/tmp/claude-0/-home-user-norte-sul-portfolio/b828416d-028b-56b8-943d-a9bc67fc20c3/scratchpad/pptx_out/caminhao_navy.png">    </p:cNvPr>
-          <p:cNvPicPr>
-            <a:picLocks noChangeAspect="1"/>
-          </p:cNvPicPr>
-          <p:nvPr/>
-        </p:nvPicPr>
-        <p:blipFill>
-          <a:blip r:embed="rId1"/>
-          <a:stretch>
-            <a:fillRect/>
-          </a:stretch>
-        </p:blipFill>
-        <p:spPr>
-          <a:xfrm>
-            <a:off x="6613855" y="1666466"/>
-            <a:ext cx="4937760" cy="2793548"/>
-          </a:xfrm>
-          <a:prstGeom prst="rect">
-            <a:avLst/>
-          </a:prstGeom>
-        </p:spPr>
-      </p:pic>
-      <p:sp>
-        <p:nvSpPr>
-          <p:cNvPr id="8" name="Shape 5"/>
+      <p:sp>
+        <p:nvSpPr>
+          <p:cNvPr id="7" name="Shape 5"/>
           <p:cNvSpPr/>
           <p:nvPr/>
         </p:nvSpPr>
@@ -2974,7 +2950,7 @@
       </p:sp>
       <p:sp>
         <p:nvSpPr>
-          <p:cNvPr id="9" name="Text 6"/>
+          <p:cNvPr id="8" name="Text 6"/>
           <p:cNvSpPr txBox="1"/>
           <p:nvPr/>
         </p:nvSpPr>
@@ -3010,7 +2986,7 @@
       </p:sp>
       <p:sp>
         <p:nvSpPr>
-          <p:cNvPr id="10" name="Shape 7"/>
+          <p:cNvPr id="9" name="Shape 7"/>
           <p:cNvSpPr/>
           <p:nvPr/>
         </p:nvSpPr>
@@ -3035,7 +3011,54 @@
       </p:sp>
       <p:pic>
         <p:nvPicPr>
-          <p:cNvPr id="11" name="Image 1" descr="/tmp/claude-0/-home-user-norte-sul-portfolio/b828416d-028b-56b8-943d-a9bc67fc20c3/scratchpad/pptx_out/logo_met.png">    </p:cNvPr>
+          <p:cNvPr id="10" name="Image 0" descr="/tmp/claude-0/-home-user-norte-sul-portfolio/b828416d-028b-56b8-943d-a9bc67fc20c3/scratchpad/pptx_out/logo_met.png">    </p:cNvPr>
+          <p:cNvPicPr>
+            <a:picLocks noChangeAspect="1"/>
+          </p:cNvPicPr>
+          <p:nvPr/>
+        </p:nvPicPr>
+        <p:blipFill>
+          <a:blip r:embed="rId1"/>
+          <a:stretch>
+            <a:fillRect/>
+          </a:stretch>
+        </p:blipFill>
+        <p:spPr>
+          <a:xfrm>
+            <a:off x="502920" y="6382512"/>
+            <a:ext cx="548640" cy="384048"/>
+          </a:xfrm>
+          <a:prstGeom prst="rect">
+            <a:avLst/>
+          </a:prstGeom>
+        </p:spPr>
+      </p:pic>
+      <p:sp>
+        <p:nvSpPr>
+          <p:cNvPr id="11" name="Shape 8"/>
+          <p:cNvSpPr/>
+          <p:nvPr/>
+        </p:nvSpPr>
+        <p:spPr>
+          <a:xfrm>
+            <a:off x="1188720" y="6419088"/>
+            <a:ext cx="0" cy="310896"/>
+          </a:xfrm>
+          <a:prstGeom prst="line">
+            <a:avLst/>
+          </a:prstGeom>
+          <a:noFill/>
+          <a:ln w="9525">
+            <a:solidFill>
+              <a:srgbClr val="C9D6EA"/>
+            </a:solidFill>
+            <a:prstDash val="solid"/>
+          </a:ln>
+        </p:spPr>
+      </p:sp>
+      <p:pic>
+        <p:nvPicPr>
+          <p:cNvPr id="12" name="Image 1" descr="/tmp/claude-0/-home-user-norte-sul-portfolio/b828416d-028b-56b8-943d-a9bc67fc20c3/scratchpad/pptx_out/logo_ns.png">    </p:cNvPr>
           <p:cNvPicPr>
             <a:picLocks noChangeAspect="1"/>
           </p:cNvPicPr>
@@ -3049,53 +3072,6 @@
         </p:blipFill>
         <p:spPr>
           <a:xfrm>
-            <a:off x="502920" y="6382512"/>
-            <a:ext cx="548640" cy="384048"/>
-          </a:xfrm>
-          <a:prstGeom prst="rect">
-            <a:avLst/>
-          </a:prstGeom>
-        </p:spPr>
-      </p:pic>
-      <p:sp>
-        <p:nvSpPr>
-          <p:cNvPr id="12" name="Shape 8"/>
-          <p:cNvSpPr/>
-          <p:nvPr/>
-        </p:nvSpPr>
-        <p:spPr>
-          <a:xfrm>
-            <a:off x="1188720" y="6419088"/>
-            <a:ext cx="0" cy="310896"/>
-          </a:xfrm>
-          <a:prstGeom prst="line">
-            <a:avLst/>
-          </a:prstGeom>
-          <a:noFill/>
-          <a:ln w="9525">
-            <a:solidFill>
-              <a:srgbClr val="C9D6EA"/>
-            </a:solidFill>
-            <a:prstDash val="solid"/>
-          </a:ln>
-        </p:spPr>
-      </p:sp>
-      <p:pic>
-        <p:nvPicPr>
-          <p:cNvPr id="13" name="Image 2" descr="/tmp/claude-0/-home-user-norte-sul-portfolio/b828416d-028b-56b8-943d-a9bc67fc20c3/scratchpad/pptx_out/logo_ns.png">    </p:cNvPr>
-          <p:cNvPicPr>
-            <a:picLocks noChangeAspect="1"/>
-          </p:cNvPicPr>
-          <p:nvPr/>
-        </p:nvPicPr>
-        <p:blipFill>
-          <a:blip r:embed="rId3"/>
-          <a:stretch>
-            <a:fillRect/>
-          </a:stretch>
-        </p:blipFill>
-        <p:spPr>
-          <a:xfrm>
             <a:off x="1325880" y="6382512"/>
             <a:ext cx="610819" cy="384048"/>
           </a:xfrm>
@@ -3106,7 +3082,7 @@
       </p:pic>
       <p:sp>
         <p:nvSpPr>
-          <p:cNvPr id="14" name="Text 9"/>
+          <p:cNvPr id="13" name="Text 9"/>
           <p:cNvSpPr txBox="1"/>
           <p:nvPr/>
         </p:nvSpPr>

</xml_diff>

<commit_message>
Planejamento Estratégico 2025-2030 no modelo Gestão + Performance
61 slides com o texto do original (só erros de digitação corrigidos), fotos
do Drive da Norte Sul, do Pinterest para temas genéricos e as históricas do
original com resolução aumentada. Corrige também marcadores de lista nas
apresentações anteriores (parágrafos com propriedades duplicadas).

Co-Authored-By: Claude Opus 5.5 <noreply@anthropic.com>
Claude-Session: https://claude.ai/code/session_019UKDqx9VshcyuwTFbJxj3E
</commit_message>
<xml_diff>
--- a/apresentacoes/Reducao-de-Perdas-de-Agua-NorteSul-com-falas.pptx
+++ b/apresentacoes/Reducao-de-Perdas-de-Agua-NorteSul-com-falas.pptx
@@ -6543,9 +6543,6 @@
               </a:rPr>
               <a:t>Q</a:t>
             </a:r>
-            <a:pPr algn="ctr" indent="0" marL="0">
-              <a:buNone/>
-            </a:pPr>
             <a:r>
               <a:rPr lang="en-US" sz="1600" b="1" baseline="-40000" dirty="0">
                 <a:solidFill>
@@ -6554,9 +6551,6 @@
               </a:rPr>
               <a:t>final</a:t>
             </a:r>
-            <a:pPr algn="ctr" indent="0" marL="0">
-              <a:buNone/>
-            </a:pPr>
             <a:r>
               <a:rPr lang="en-US" sz="1600" b="1" dirty="0">
                 <a:solidFill>
@@ -6565,9 +6559,6 @@
               </a:rPr>
               <a:t> / Q</a:t>
             </a:r>
-            <a:pPr algn="ctr" indent="0" marL="0">
-              <a:buNone/>
-            </a:pPr>
             <a:r>
               <a:rPr lang="en-US" sz="1600" b="1" baseline="-40000" dirty="0">
                 <a:solidFill>
@@ -6576,9 +6567,6 @@
               </a:rPr>
               <a:t>inicial</a:t>
             </a:r>
-            <a:pPr algn="ctr" indent="0" marL="0">
-              <a:buNone/>
-            </a:pPr>
             <a:r>
               <a:rPr lang="en-US" sz="1600" b="1" dirty="0">
                 <a:solidFill>
@@ -6587,9 +6575,6 @@
               </a:rPr>
               <a:t> = ( P</a:t>
             </a:r>
-            <a:pPr algn="ctr" indent="0" marL="0">
-              <a:buNone/>
-            </a:pPr>
             <a:r>
               <a:rPr lang="en-US" sz="1600" b="1" baseline="-40000" dirty="0">
                 <a:solidFill>
@@ -6598,9 +6583,6 @@
               </a:rPr>
               <a:t>final</a:t>
             </a:r>
-            <a:pPr algn="ctr" indent="0" marL="0">
-              <a:buNone/>
-            </a:pPr>
             <a:r>
               <a:rPr lang="en-US" sz="1600" b="1" dirty="0">
                 <a:solidFill>
@@ -6609,9 +6591,6 @@
               </a:rPr>
               <a:t> / P</a:t>
             </a:r>
-            <a:pPr algn="ctr" indent="0" marL="0">
-              <a:buNone/>
-            </a:pPr>
             <a:r>
               <a:rPr lang="en-US" sz="1600" b="1" baseline="-40000" dirty="0">
                 <a:solidFill>
@@ -6620,9 +6599,6 @@
               </a:rPr>
               <a:t>inicial</a:t>
             </a:r>
-            <a:pPr algn="ctr" indent="0" marL="0">
-              <a:buNone/>
-            </a:pPr>
             <a:r>
               <a:rPr lang="en-US" sz="1600" b="1" dirty="0">
                 <a:solidFill>
@@ -6631,9 +6607,6 @@
               </a:rPr>
               <a:t> )</a:t>
             </a:r>
-            <a:pPr algn="ctr" indent="0" marL="0">
-              <a:buNone/>
-            </a:pPr>
             <a:r>
               <a:rPr lang="en-US" sz="1600" b="1" baseline="30000" dirty="0">
                 <a:solidFill>
@@ -6642,9 +6615,6 @@
               </a:rPr>
               <a:t>n</a:t>
             </a:r>
-            <a:pPr algn="ctr" indent="0" marL="0">
-              <a:buNone/>
-            </a:pPr>
             <a:r>
               <a:rPr lang="en-US" sz="1600" b="1" dirty="0">
                 <a:solidFill>
@@ -6653,9 +6623,6 @@
               </a:rPr>
               <a:t>   →   Q</a:t>
             </a:r>
-            <a:pPr algn="ctr" indent="0" marL="0">
-              <a:buNone/>
-            </a:pPr>
             <a:r>
               <a:rPr lang="en-US" sz="1600" b="1" baseline="-40000" dirty="0">
                 <a:solidFill>
@@ -6664,9 +6631,6 @@
               </a:rPr>
               <a:t>final</a:t>
             </a:r>
-            <a:pPr algn="ctr" indent="0" marL="0">
-              <a:buNone/>
-            </a:pPr>
             <a:r>
               <a:rPr lang="en-US" sz="1600" b="1" dirty="0">
                 <a:solidFill>
@@ -6675,9 +6639,6 @@
               </a:rPr>
               <a:t> = Q</a:t>
             </a:r>
-            <a:pPr algn="ctr" indent="0" marL="0">
-              <a:buNone/>
-            </a:pPr>
             <a:r>
               <a:rPr lang="en-US" sz="1600" b="1" baseline="-40000" dirty="0">
                 <a:solidFill>
@@ -6686,9 +6647,6 @@
               </a:rPr>
               <a:t>inicial</a:t>
             </a:r>
-            <a:pPr algn="ctr" indent="0" marL="0">
-              <a:buNone/>
-            </a:pPr>
             <a:r>
               <a:rPr lang="en-US" sz="1600" b="1" dirty="0">
                 <a:solidFill>
@@ -6697,9 +6655,6 @@
               </a:rPr>
               <a:t> · ( P</a:t>
             </a:r>
-            <a:pPr algn="ctr" indent="0" marL="0">
-              <a:buNone/>
-            </a:pPr>
             <a:r>
               <a:rPr lang="en-US" sz="1600" b="1" baseline="-40000" dirty="0">
                 <a:solidFill>
@@ -6708,9 +6663,6 @@
               </a:rPr>
               <a:t>final</a:t>
             </a:r>
-            <a:pPr algn="ctr" indent="0" marL="0">
-              <a:buNone/>
-            </a:pPr>
             <a:r>
               <a:rPr lang="en-US" sz="1600" b="1" dirty="0">
                 <a:solidFill>
@@ -6719,9 +6671,6 @@
               </a:rPr>
               <a:t> / P</a:t>
             </a:r>
-            <a:pPr algn="ctr" indent="0" marL="0">
-              <a:buNone/>
-            </a:pPr>
             <a:r>
               <a:rPr lang="en-US" sz="1600" b="1" baseline="-40000" dirty="0">
                 <a:solidFill>
@@ -6730,9 +6679,6 @@
               </a:rPr>
               <a:t>inicial</a:t>
             </a:r>
-            <a:pPr algn="ctr" indent="0" marL="0">
-              <a:buNone/>
-            </a:pPr>
             <a:r>
               <a:rPr lang="en-US" sz="1600" b="1" dirty="0">
                 <a:solidFill>
@@ -6741,9 +6687,6 @@
               </a:rPr>
               <a:t> )</a:t>
             </a:r>
-            <a:pPr algn="ctr" indent="0" marL="0">
-              <a:buNone/>
-            </a:pPr>
             <a:r>
               <a:rPr lang="en-US" sz="1600" b="1" baseline="30000" dirty="0">
                 <a:solidFill>
@@ -6805,19 +6748,35 @@
               </a:rPr>
               <a:t>Q final: </a:t>
             </a:r>
+            <a:r>
+              <a:rPr lang="en-US" sz="1300" dirty="0">
+                <a:solidFill>
+                  <a:srgbClr val="5B6B88"/>
+                </a:solidFill>
+              </a:rPr>
+              <a:t>Vazão dos vazamentos após a redução da pressão.</a:t>
+            </a:r>
+            <a:endParaRPr lang="en-US" sz="1300" dirty="0"/>
+          </a:p>
+          <a:p>
             <a:pPr indent="0" marL="0">
-              <a:spcAft>
-                <a:spcPts val="400"/>
-              </a:spcAft>
-              <a:buNone/>
-            </a:pPr>
+              <a:buNone/>
+            </a:pPr>
+            <a:r>
+              <a:rPr lang="en-US" sz="1300" b="1" dirty="0">
+                <a:solidFill>
+                  <a:srgbClr val="5B6B88"/>
+                </a:solidFill>
+              </a:rPr>
+              <a:t>Q inicial: </a:t>
+            </a:r>
             <a:r>
               <a:rPr lang="en-US" sz="1300" dirty="0">
                 <a:solidFill>
                   <a:srgbClr val="5B6B88"/>
                 </a:solidFill>
               </a:rPr>
-              <a:t>Vazão dos vazamentos após a redução da pressão.</a:t>
+              <a:t>Vazão antes dos vazamentos antes da redução da pressão.</a:t>
             </a:r>
             <a:endParaRPr lang="en-US" sz="1300" dirty="0"/>
           </a:p>
@@ -6831,39 +6790,8 @@
                   <a:srgbClr val="5B6B88"/>
                 </a:solidFill>
               </a:rPr>
-              <a:t>Q inicial: </a:t>
-            </a:r>
-            <a:pPr indent="0" marL="0">
-              <a:spcAft>
-                <a:spcPts val="400"/>
-              </a:spcAft>
-              <a:buNone/>
-            </a:pPr>
-            <a:r>
-              <a:rPr lang="en-US" sz="1300" dirty="0">
-                <a:solidFill>
-                  <a:srgbClr val="5B6B88"/>
-                </a:solidFill>
-              </a:rPr>
-              <a:t>Vazão antes dos vazamentos antes da redução da pressão.</a:t>
-            </a:r>
-            <a:endParaRPr lang="en-US" sz="1300" dirty="0"/>
-          </a:p>
-          <a:p>
-            <a:pPr indent="0" marL="0">
-              <a:buNone/>
-            </a:pPr>
-            <a:r>
-              <a:rPr lang="en-US" sz="1300" b="1" dirty="0">
-                <a:solidFill>
-                  <a:srgbClr val="5B6B88"/>
-                </a:solidFill>
-              </a:rPr>
               <a:t>n: </a:t>
             </a:r>
-            <a:pPr indent="0" marL="0">
-              <a:buNone/>
-            </a:pPr>
             <a:r>
               <a:rPr lang="en-US" sz="1300" dirty="0">
                 <a:solidFill>
@@ -7239,9 +7167,6 @@
               </a:rPr>
               <a:t>31</a:t>
             </a:r>
-            <a:pPr indent="0" marL="0">
-              <a:buNone/>
-            </a:pPr>
             <a:r>
               <a:rPr lang="en-US" sz="1500" b="1" dirty="0">
                 <a:solidFill>
@@ -7358,9 +7283,6 @@
               </a:rPr>
               <a:t>21</a:t>
             </a:r>
-            <a:pPr indent="0" marL="0">
-              <a:buNone/>
-            </a:pPr>
             <a:r>
               <a:rPr lang="en-US" sz="1500" b="1" dirty="0">
                 <a:solidFill>
@@ -8014,9 +7936,6 @@
               </a:rPr>
               <a:t>10</a:t>
             </a:r>
-            <a:pPr indent="0" marL="0">
-              <a:buNone/>
-            </a:pPr>
             <a:r>
               <a:rPr lang="en-US" sz="2200" b="1" dirty="0">
                 <a:solidFill>

</xml_diff>